<commit_message>
v784 — evidence badges lead with the luck test in plain English; precise stats kept in brackets; guides refreshed
</commit_message>
<xml_diff>
--- a/guides/Insight-Trading-Beginners-Guide.pptx
+++ b/guides/Insight-Trading-Beginners-Guide.pptx
@@ -2292,7 +2292,7 @@
                 <a:ea typeface="Calibri" pitchFamily="34" charset="-122"/>
                 <a:cs typeface="Calibri" pitchFamily="34" charset="-120"/>
               </a:rPr>
-              <a:t>Every signal is replayed against history and graded: how did shares do after it fired, versus the market?</a:t>
+              <a:t>Every signal is replayed against history and asked one question: after it fired, did shares beat the market — and could the answer just be luck? A handful of good results might be. Hundreds of steady ones cannot be.</a:t>
             </a:r>
             <a:endParaRPr lang="en-US" sz="1500" dirty="0"/>
           </a:p>
@@ -2514,7 +2514,7 @@
                 <a:ea typeface="Calibri" pitchFamily="34" charset="-122"/>
                 <a:cs typeface="Calibri" pitchFamily="34" charset="-120"/>
               </a:rPr>
-              <a:t>edge at least 2.5x its margin of error</a:t>
+              <a:t>luck practically ruled out</a:t>
             </a:r>
             <a:endParaRPr lang="en-US" sz="1050" dirty="0"/>
           </a:p>
@@ -2529,7 +2529,7 @@
         <p:spPr>
           <a:xfrm>
             <a:off x="2926080" y="2697480"/>
-            <a:ext cx="2377440" cy="457200"/>
+            <a:ext cx="2560320" cy="457200"/>
           </a:xfrm>
           <a:prstGeom prst="rect">
             <a:avLst/>
@@ -2553,7 +2553,7 @@
                 <a:ea typeface="Calibri" pitchFamily="34" charset="-122"/>
                 <a:cs typeface="Calibri" pitchFamily="34" charset="-120"/>
               </a:rPr>
-              <a:t>at least 1.5x</a:t>
+              <a:t>looks real — thinner evidence</a:t>
             </a:r>
             <a:endParaRPr lang="en-US" sz="1050" dirty="0"/>
           </a:p>
@@ -2592,7 +2592,7 @@
                 <a:ea typeface="Calibri" pitchFamily="34" charset="-122"/>
                 <a:cs typeface="Calibri" pitchFamily="34" charset="-120"/>
               </a:rPr>
-              <a:t>history existed, no edge found</a:t>
+              <a:t>luck could still explain it</a:t>
             </a:r>
             <a:endParaRPr lang="en-US" sz="1050" dirty="0"/>
           </a:p>

</xml_diff>